<commit_message>
Supply Voltage schematic adapted
</commit_message>
<xml_diff>
--- a/Images/SupplyVoltage.pptx
+++ b/Images/SupplyVoltage.pptx
@@ -288,7 +288,8 @@
           <a:p>
             <a:fld id="{26A4EE3E-C51C-46FF-A86D-714B8E2F6002}" type="datetimeFigureOut">
               <a:rPr lang="de-DE" smtClean="0"/>
-              <a:t>19.02.2026</a:t>
+              <a:pPr/>
+              <a:t>24.02.2026</a:t>
             </a:fld>
             <a:endParaRPr lang="de-DE"/>
           </a:p>
@@ -330,6 +331,7 @@
           <a:p>
             <a:fld id="{D868F6A0-EAC2-4ADD-93DE-56541012D13E}" type="slidenum">
               <a:rPr lang="de-DE" smtClean="0"/>
+              <a:pPr/>
               <a:t>‹Nr.›</a:t>
             </a:fld>
             <a:endParaRPr lang="de-DE"/>
@@ -453,7 +455,8 @@
           <a:p>
             <a:fld id="{26A4EE3E-C51C-46FF-A86D-714B8E2F6002}" type="datetimeFigureOut">
               <a:rPr lang="de-DE" smtClean="0"/>
-              <a:t>19.02.2026</a:t>
+              <a:pPr/>
+              <a:t>24.02.2026</a:t>
             </a:fld>
             <a:endParaRPr lang="de-DE"/>
           </a:p>
@@ -495,6 +498,7 @@
           <a:p>
             <a:fld id="{D868F6A0-EAC2-4ADD-93DE-56541012D13E}" type="slidenum">
               <a:rPr lang="de-DE" smtClean="0"/>
+              <a:pPr/>
               <a:t>‹Nr.›</a:t>
             </a:fld>
             <a:endParaRPr lang="de-DE"/>
@@ -628,7 +632,8 @@
           <a:p>
             <a:fld id="{26A4EE3E-C51C-46FF-A86D-714B8E2F6002}" type="datetimeFigureOut">
               <a:rPr lang="de-DE" smtClean="0"/>
-              <a:t>19.02.2026</a:t>
+              <a:pPr/>
+              <a:t>24.02.2026</a:t>
             </a:fld>
             <a:endParaRPr lang="de-DE"/>
           </a:p>
@@ -670,6 +675,7 @@
           <a:p>
             <a:fld id="{D868F6A0-EAC2-4ADD-93DE-56541012D13E}" type="slidenum">
               <a:rPr lang="de-DE" smtClean="0"/>
+              <a:pPr/>
               <a:t>‹Nr.›</a:t>
             </a:fld>
             <a:endParaRPr lang="de-DE"/>
@@ -793,7 +799,8 @@
           <a:p>
             <a:fld id="{26A4EE3E-C51C-46FF-A86D-714B8E2F6002}" type="datetimeFigureOut">
               <a:rPr lang="de-DE" smtClean="0"/>
-              <a:t>19.02.2026</a:t>
+              <a:pPr/>
+              <a:t>24.02.2026</a:t>
             </a:fld>
             <a:endParaRPr lang="de-DE"/>
           </a:p>
@@ -835,6 +842,7 @@
           <a:p>
             <a:fld id="{D868F6A0-EAC2-4ADD-93DE-56541012D13E}" type="slidenum">
               <a:rPr lang="de-DE" smtClean="0"/>
+              <a:pPr/>
               <a:t>‹Nr.›</a:t>
             </a:fld>
             <a:endParaRPr lang="de-DE"/>
@@ -1034,7 +1042,8 @@
           <a:p>
             <a:fld id="{26A4EE3E-C51C-46FF-A86D-714B8E2F6002}" type="datetimeFigureOut">
               <a:rPr lang="de-DE" smtClean="0"/>
-              <a:t>19.02.2026</a:t>
+              <a:pPr/>
+              <a:t>24.02.2026</a:t>
             </a:fld>
             <a:endParaRPr lang="de-DE"/>
           </a:p>
@@ -1076,6 +1085,7 @@
           <a:p>
             <a:fld id="{D868F6A0-EAC2-4ADD-93DE-56541012D13E}" type="slidenum">
               <a:rPr lang="de-DE" smtClean="0"/>
+              <a:pPr/>
               <a:t>‹Nr.›</a:t>
             </a:fld>
             <a:endParaRPr lang="de-DE"/>
@@ -1317,7 +1327,8 @@
           <a:p>
             <a:fld id="{26A4EE3E-C51C-46FF-A86D-714B8E2F6002}" type="datetimeFigureOut">
               <a:rPr lang="de-DE" smtClean="0"/>
-              <a:t>19.02.2026</a:t>
+              <a:pPr/>
+              <a:t>24.02.2026</a:t>
             </a:fld>
             <a:endParaRPr lang="de-DE"/>
           </a:p>
@@ -1359,6 +1370,7 @@
           <a:p>
             <a:fld id="{D868F6A0-EAC2-4ADD-93DE-56541012D13E}" type="slidenum">
               <a:rPr lang="de-DE" smtClean="0"/>
+              <a:pPr/>
               <a:t>‹Nr.›</a:t>
             </a:fld>
             <a:endParaRPr lang="de-DE"/>
@@ -1734,7 +1746,8 @@
           <a:p>
             <a:fld id="{26A4EE3E-C51C-46FF-A86D-714B8E2F6002}" type="datetimeFigureOut">
               <a:rPr lang="de-DE" smtClean="0"/>
-              <a:t>19.02.2026</a:t>
+              <a:pPr/>
+              <a:t>24.02.2026</a:t>
             </a:fld>
             <a:endParaRPr lang="de-DE"/>
           </a:p>
@@ -1776,6 +1789,7 @@
           <a:p>
             <a:fld id="{D868F6A0-EAC2-4ADD-93DE-56541012D13E}" type="slidenum">
               <a:rPr lang="de-DE" smtClean="0"/>
+              <a:pPr/>
               <a:t>‹Nr.›</a:t>
             </a:fld>
             <a:endParaRPr lang="de-DE"/>
@@ -1847,7 +1861,8 @@
           <a:p>
             <a:fld id="{26A4EE3E-C51C-46FF-A86D-714B8E2F6002}" type="datetimeFigureOut">
               <a:rPr lang="de-DE" smtClean="0"/>
-              <a:t>19.02.2026</a:t>
+              <a:pPr/>
+              <a:t>24.02.2026</a:t>
             </a:fld>
             <a:endParaRPr lang="de-DE"/>
           </a:p>
@@ -1889,6 +1904,7 @@
           <a:p>
             <a:fld id="{D868F6A0-EAC2-4ADD-93DE-56541012D13E}" type="slidenum">
               <a:rPr lang="de-DE" smtClean="0"/>
+              <a:pPr/>
               <a:t>‹Nr.›</a:t>
             </a:fld>
             <a:endParaRPr lang="de-DE"/>
@@ -1937,7 +1953,8 @@
           <a:p>
             <a:fld id="{26A4EE3E-C51C-46FF-A86D-714B8E2F6002}" type="datetimeFigureOut">
               <a:rPr lang="de-DE" smtClean="0"/>
-              <a:t>19.02.2026</a:t>
+              <a:pPr/>
+              <a:t>24.02.2026</a:t>
             </a:fld>
             <a:endParaRPr lang="de-DE"/>
           </a:p>
@@ -1979,6 +1996,7 @@
           <a:p>
             <a:fld id="{D868F6A0-EAC2-4ADD-93DE-56541012D13E}" type="slidenum">
               <a:rPr lang="de-DE" smtClean="0"/>
+              <a:pPr/>
               <a:t>‹Nr.›</a:t>
             </a:fld>
             <a:endParaRPr lang="de-DE"/>
@@ -2209,7 +2227,8 @@
           <a:p>
             <a:fld id="{26A4EE3E-C51C-46FF-A86D-714B8E2F6002}" type="datetimeFigureOut">
               <a:rPr lang="de-DE" smtClean="0"/>
-              <a:t>19.02.2026</a:t>
+              <a:pPr/>
+              <a:t>24.02.2026</a:t>
             </a:fld>
             <a:endParaRPr lang="de-DE"/>
           </a:p>
@@ -2251,6 +2270,7 @@
           <a:p>
             <a:fld id="{D868F6A0-EAC2-4ADD-93DE-56541012D13E}" type="slidenum">
               <a:rPr lang="de-DE" smtClean="0"/>
+              <a:pPr/>
               <a:t>‹Nr.›</a:t>
             </a:fld>
             <a:endParaRPr lang="de-DE"/>
@@ -2457,7 +2477,8 @@
           <a:p>
             <a:fld id="{26A4EE3E-C51C-46FF-A86D-714B8E2F6002}" type="datetimeFigureOut">
               <a:rPr lang="de-DE" smtClean="0"/>
-              <a:t>19.02.2026</a:t>
+              <a:pPr/>
+              <a:t>24.02.2026</a:t>
             </a:fld>
             <a:endParaRPr lang="de-DE"/>
           </a:p>
@@ -2499,6 +2520,7 @@
           <a:p>
             <a:fld id="{D868F6A0-EAC2-4ADD-93DE-56541012D13E}" type="slidenum">
               <a:rPr lang="de-DE" smtClean="0"/>
+              <a:pPr/>
               <a:t>‹Nr.›</a:t>
             </a:fld>
             <a:endParaRPr lang="de-DE"/>
@@ -2665,7 +2687,8 @@
           <a:p>
             <a:fld id="{26A4EE3E-C51C-46FF-A86D-714B8E2F6002}" type="datetimeFigureOut">
               <a:rPr lang="de-DE" smtClean="0"/>
-              <a:t>19.02.2026</a:t>
+              <a:pPr/>
+              <a:t>24.02.2026</a:t>
             </a:fld>
             <a:endParaRPr lang="de-DE"/>
           </a:p>
@@ -2743,6 +2766,7 @@
           <a:p>
             <a:fld id="{D868F6A0-EAC2-4ADD-93DE-56541012D13E}" type="slidenum">
               <a:rPr lang="de-DE" smtClean="0"/>
+              <a:pPr/>
               <a:t>‹Nr.›</a:t>
             </a:fld>
             <a:endParaRPr lang="de-DE"/>
@@ -3037,43 +3061,18 @@
       </p:grpSpPr>
       <p:grpSp>
         <p:nvGrpSpPr>
-          <p:cNvPr id="17" name="Gruppieren 16"/>
+          <p:cNvPr id="19" name="Gruppieren 18"/>
           <p:cNvGrpSpPr/>
           <p:nvPr/>
         </p:nvGrpSpPr>
         <p:grpSpPr>
           <a:xfrm>
-            <a:off x="684074" y="2420676"/>
-            <a:ext cx="7567350" cy="2926118"/>
-            <a:chOff x="684074" y="2420676"/>
-            <a:chExt cx="7567350" cy="2926118"/>
+            <a:off x="899592" y="2420888"/>
+            <a:ext cx="7179499" cy="2925906"/>
+            <a:chOff x="899592" y="2420888"/>
+            <a:chExt cx="7179499" cy="2925906"/>
           </a:xfrm>
         </p:grpSpPr>
-        <p:pic>
-          <p:nvPicPr>
-            <p:cNvPr id="5" name="Grafik 4" descr="VoltageSupply.png"/>
-            <p:cNvPicPr>
-              <a:picLocks noChangeAspect="1"/>
-            </p:cNvPicPr>
-            <p:nvPr/>
-          </p:nvPicPr>
-          <p:blipFill>
-            <a:blip r:embed="rId2" cstate="print"/>
-            <a:srcRect l="7686" t="36485" r="7281" b="16722"/>
-            <a:stretch>
-              <a:fillRect/>
-            </a:stretch>
-          </p:blipFill>
-          <p:spPr>
-            <a:xfrm>
-              <a:off x="684074" y="2420676"/>
-              <a:ext cx="7567350" cy="2216150"/>
-            </a:xfrm>
-            <a:prstGeom prst="rect">
-              <a:avLst/>
-            </a:prstGeom>
-          </p:spPr>
-        </p:pic>
         <p:sp>
           <p:nvSpPr>
             <p:cNvPr id="9" name="Geschweifte Klammer links 8"/>
@@ -3374,6 +3373,31 @@
             </a:p>
           </p:txBody>
         </p:sp>
+        <p:pic>
+          <p:nvPicPr>
+            <p:cNvPr id="18" name="Grafik 17" descr="VoltageSupply.png"/>
+            <p:cNvPicPr>
+              <a:picLocks noChangeAspect="1"/>
+            </p:cNvPicPr>
+            <p:nvPr/>
+          </p:nvPicPr>
+          <p:blipFill>
+            <a:blip r:embed="rId2" cstate="print"/>
+            <a:srcRect l="12815" t="30301" r="8669" b="34158"/>
+            <a:stretch>
+              <a:fillRect/>
+            </a:stretch>
+          </p:blipFill>
+          <p:spPr>
+            <a:xfrm>
+              <a:off x="899592" y="2420888"/>
+              <a:ext cx="7179499" cy="2223267"/>
+            </a:xfrm>
+            <a:prstGeom prst="rect">
+              <a:avLst/>
+            </a:prstGeom>
+          </p:spPr>
+        </p:pic>
       </p:grpSp>
     </p:spTree>
   </p:cSld>

</xml_diff>

<commit_message>
Supply Voltage image adapted
</commit_message>
<xml_diff>
--- a/Images/SupplyVoltage.pptx
+++ b/Images/SupplyVoltage.pptx
@@ -104,6 +104,22 @@
       </a:defRPr>
     </a:lvl9pPr>
   </p:defaultTextStyle>
+  <p:extLst>
+    <p:ext uri="{EFAFB233-063F-42B5-8137-9DF3F51BA10A}">
+      <p15:sldGuideLst xmlns:p15="http://schemas.microsoft.com/office/powerpoint/2012/main">
+        <p15:guide id="1" orient="horz" pos="2160">
+          <p15:clr>
+            <a:srgbClr val="A4A3A4"/>
+          </p15:clr>
+        </p15:guide>
+        <p15:guide id="2" pos="2880">
+          <p15:clr>
+            <a:srgbClr val="A4A3A4"/>
+          </p15:clr>
+        </p15:guide>
+      </p15:sldGuideLst>
+    </p:ext>
+  </p:extLst>
 </p:presentation>
 </file>
 
@@ -145,10 +161,9 @@
           <a:lstStyle/>
           <a:p>
             <a:r>
-              <a:rPr lang="de-DE" smtClean="0"/>
+              <a:rPr lang="de-DE"/>
               <a:t>Titelmasterformat durch Klicken bearbeiten</a:t>
             </a:r>
-            <a:endParaRPr lang="de-DE"/>
           </a:p>
         </p:txBody>
       </p:sp>
@@ -264,10 +279,9 @@
           </a:lstStyle>
           <a:p>
             <a:r>
-              <a:rPr lang="de-DE" smtClean="0"/>
+              <a:rPr lang="de-DE"/>
               <a:t>Formatvorlage des Untertitelmasters durch Klicken bearbeiten</a:t>
             </a:r>
-            <a:endParaRPr lang="de-DE"/>
           </a:p>
         </p:txBody>
       </p:sp>
@@ -379,10 +393,9 @@
           <a:lstStyle/>
           <a:p>
             <a:r>
-              <a:rPr lang="de-DE" smtClean="0"/>
+              <a:rPr lang="de-DE"/>
               <a:t>Titelmasterformat durch Klicken bearbeiten</a:t>
             </a:r>
-            <a:endParaRPr lang="de-DE"/>
           </a:p>
         </p:txBody>
       </p:sp>
@@ -403,38 +416,37 @@
           <a:p>
             <a:pPr lvl="0"/>
             <a:r>
-              <a:rPr lang="de-DE" smtClean="0"/>
+              <a:rPr lang="de-DE"/>
               <a:t>Textmasterformate durch Klicken bearbeiten</a:t>
             </a:r>
           </a:p>
           <a:p>
             <a:pPr lvl="1"/>
             <a:r>
-              <a:rPr lang="de-DE" smtClean="0"/>
+              <a:rPr lang="de-DE"/>
               <a:t>Zweite Ebene</a:t>
             </a:r>
           </a:p>
           <a:p>
             <a:pPr lvl="2"/>
             <a:r>
-              <a:rPr lang="de-DE" smtClean="0"/>
+              <a:rPr lang="de-DE"/>
               <a:t>Dritte Ebene</a:t>
             </a:r>
           </a:p>
           <a:p>
             <a:pPr lvl="3"/>
             <a:r>
-              <a:rPr lang="de-DE" smtClean="0"/>
+              <a:rPr lang="de-DE"/>
               <a:t>Vierte Ebene</a:t>
             </a:r>
           </a:p>
           <a:p>
             <a:pPr lvl="4"/>
             <a:r>
-              <a:rPr lang="de-DE" smtClean="0"/>
+              <a:rPr lang="de-DE"/>
               <a:t>Fünfte Ebene</a:t>
             </a:r>
-            <a:endParaRPr lang="de-DE"/>
           </a:p>
         </p:txBody>
       </p:sp>
@@ -551,10 +563,9 @@
           <a:lstStyle/>
           <a:p>
             <a:r>
-              <a:rPr lang="de-DE" smtClean="0"/>
+              <a:rPr lang="de-DE"/>
               <a:t>Titelmasterformat durch Klicken bearbeiten</a:t>
             </a:r>
-            <a:endParaRPr lang="de-DE"/>
           </a:p>
         </p:txBody>
       </p:sp>
@@ -580,38 +591,37 @@
           <a:p>
             <a:pPr lvl="0"/>
             <a:r>
-              <a:rPr lang="de-DE" smtClean="0"/>
+              <a:rPr lang="de-DE"/>
               <a:t>Textmasterformate durch Klicken bearbeiten</a:t>
             </a:r>
           </a:p>
           <a:p>
             <a:pPr lvl="1"/>
             <a:r>
-              <a:rPr lang="de-DE" smtClean="0"/>
+              <a:rPr lang="de-DE"/>
               <a:t>Zweite Ebene</a:t>
             </a:r>
           </a:p>
           <a:p>
             <a:pPr lvl="2"/>
             <a:r>
-              <a:rPr lang="de-DE" smtClean="0"/>
+              <a:rPr lang="de-DE"/>
               <a:t>Dritte Ebene</a:t>
             </a:r>
           </a:p>
           <a:p>
             <a:pPr lvl="3"/>
             <a:r>
-              <a:rPr lang="de-DE" smtClean="0"/>
+              <a:rPr lang="de-DE"/>
               <a:t>Vierte Ebene</a:t>
             </a:r>
           </a:p>
           <a:p>
             <a:pPr lvl="4"/>
             <a:r>
-              <a:rPr lang="de-DE" smtClean="0"/>
+              <a:rPr lang="de-DE"/>
               <a:t>Fünfte Ebene</a:t>
             </a:r>
-            <a:endParaRPr lang="de-DE"/>
           </a:p>
         </p:txBody>
       </p:sp>
@@ -723,10 +733,9 @@
           <a:lstStyle/>
           <a:p>
             <a:r>
-              <a:rPr lang="de-DE" smtClean="0"/>
+              <a:rPr lang="de-DE"/>
               <a:t>Titelmasterformat durch Klicken bearbeiten</a:t>
             </a:r>
-            <a:endParaRPr lang="de-DE"/>
           </a:p>
         </p:txBody>
       </p:sp>
@@ -747,38 +756,37 @@
           <a:p>
             <a:pPr lvl="0"/>
             <a:r>
-              <a:rPr lang="de-DE" smtClean="0"/>
+              <a:rPr lang="de-DE"/>
               <a:t>Textmasterformate durch Klicken bearbeiten</a:t>
             </a:r>
           </a:p>
           <a:p>
             <a:pPr lvl="1"/>
             <a:r>
-              <a:rPr lang="de-DE" smtClean="0"/>
+              <a:rPr lang="de-DE"/>
               <a:t>Zweite Ebene</a:t>
             </a:r>
           </a:p>
           <a:p>
             <a:pPr lvl="2"/>
             <a:r>
-              <a:rPr lang="de-DE" smtClean="0"/>
+              <a:rPr lang="de-DE"/>
               <a:t>Dritte Ebene</a:t>
             </a:r>
           </a:p>
           <a:p>
             <a:pPr lvl="3"/>
             <a:r>
-              <a:rPr lang="de-DE" smtClean="0"/>
+              <a:rPr lang="de-DE"/>
               <a:t>Vierte Ebene</a:t>
             </a:r>
           </a:p>
           <a:p>
             <a:pPr lvl="4"/>
             <a:r>
-              <a:rPr lang="de-DE" smtClean="0"/>
+              <a:rPr lang="de-DE"/>
               <a:t>Fünfte Ebene</a:t>
             </a:r>
-            <a:endParaRPr lang="de-DE"/>
           </a:p>
         </p:txBody>
       </p:sp>
@@ -899,10 +907,9 @@
           </a:lstStyle>
           <a:p>
             <a:r>
-              <a:rPr lang="de-DE" smtClean="0"/>
+              <a:rPr lang="de-DE"/>
               <a:t>Titelmasterformat durch Klicken bearbeiten</a:t>
             </a:r>
-            <a:endParaRPr lang="de-DE"/>
           </a:p>
         </p:txBody>
       </p:sp>
@@ -1019,7 +1026,7 @@
           <a:p>
             <a:pPr lvl="0"/>
             <a:r>
-              <a:rPr lang="de-DE" smtClean="0"/>
+              <a:rPr lang="de-DE"/>
               <a:t>Textmasterformate durch Klicken bearbeiten</a:t>
             </a:r>
           </a:p>
@@ -1133,10 +1140,9 @@
           <a:lstStyle/>
           <a:p>
             <a:r>
-              <a:rPr lang="de-DE" smtClean="0"/>
+              <a:rPr lang="de-DE"/>
               <a:t>Titelmasterformat durch Klicken bearbeiten</a:t>
             </a:r>
-            <a:endParaRPr lang="de-DE"/>
           </a:p>
         </p:txBody>
       </p:sp>
@@ -1190,38 +1196,37 @@
           <a:p>
             <a:pPr lvl="0"/>
             <a:r>
-              <a:rPr lang="de-DE" smtClean="0"/>
+              <a:rPr lang="de-DE"/>
               <a:t>Textmasterformate durch Klicken bearbeiten</a:t>
             </a:r>
           </a:p>
           <a:p>
             <a:pPr lvl="1"/>
             <a:r>
-              <a:rPr lang="de-DE" smtClean="0"/>
+              <a:rPr lang="de-DE"/>
               <a:t>Zweite Ebene</a:t>
             </a:r>
           </a:p>
           <a:p>
             <a:pPr lvl="2"/>
             <a:r>
-              <a:rPr lang="de-DE" smtClean="0"/>
+              <a:rPr lang="de-DE"/>
               <a:t>Dritte Ebene</a:t>
             </a:r>
           </a:p>
           <a:p>
             <a:pPr lvl="3"/>
             <a:r>
-              <a:rPr lang="de-DE" smtClean="0"/>
+              <a:rPr lang="de-DE"/>
               <a:t>Vierte Ebene</a:t>
             </a:r>
           </a:p>
           <a:p>
             <a:pPr lvl="4"/>
             <a:r>
-              <a:rPr lang="de-DE" smtClean="0"/>
+              <a:rPr lang="de-DE"/>
               <a:t>Fünfte Ebene</a:t>
             </a:r>
-            <a:endParaRPr lang="de-DE"/>
           </a:p>
         </p:txBody>
       </p:sp>
@@ -1275,38 +1280,37 @@
           <a:p>
             <a:pPr lvl="0"/>
             <a:r>
-              <a:rPr lang="de-DE" smtClean="0"/>
+              <a:rPr lang="de-DE"/>
               <a:t>Textmasterformate durch Klicken bearbeiten</a:t>
             </a:r>
           </a:p>
           <a:p>
             <a:pPr lvl="1"/>
             <a:r>
-              <a:rPr lang="de-DE" smtClean="0"/>
+              <a:rPr lang="de-DE"/>
               <a:t>Zweite Ebene</a:t>
             </a:r>
           </a:p>
           <a:p>
             <a:pPr lvl="2"/>
             <a:r>
-              <a:rPr lang="de-DE" smtClean="0"/>
+              <a:rPr lang="de-DE"/>
               <a:t>Dritte Ebene</a:t>
             </a:r>
           </a:p>
           <a:p>
             <a:pPr lvl="3"/>
             <a:r>
-              <a:rPr lang="de-DE" smtClean="0"/>
+              <a:rPr lang="de-DE"/>
               <a:t>Vierte Ebene</a:t>
             </a:r>
           </a:p>
           <a:p>
             <a:pPr lvl="4"/>
             <a:r>
-              <a:rPr lang="de-DE" smtClean="0"/>
+              <a:rPr lang="de-DE"/>
               <a:t>Fünfte Ebene</a:t>
             </a:r>
-            <a:endParaRPr lang="de-DE"/>
           </a:p>
         </p:txBody>
       </p:sp>
@@ -1422,10 +1426,9 @@
           </a:lstStyle>
           <a:p>
             <a:r>
-              <a:rPr lang="de-DE" smtClean="0"/>
+              <a:rPr lang="de-DE"/>
               <a:t>Titelmasterformat durch Klicken bearbeiten</a:t>
             </a:r>
-            <a:endParaRPr lang="de-DE"/>
           </a:p>
         </p:txBody>
       </p:sp>
@@ -1488,7 +1491,7 @@
           <a:p>
             <a:pPr lvl="0"/>
             <a:r>
-              <a:rPr lang="de-DE" smtClean="0"/>
+              <a:rPr lang="de-DE"/>
               <a:t>Textmasterformate durch Klicken bearbeiten</a:t>
             </a:r>
           </a:p>
@@ -1544,38 +1547,37 @@
           <a:p>
             <a:pPr lvl="0"/>
             <a:r>
-              <a:rPr lang="de-DE" smtClean="0"/>
+              <a:rPr lang="de-DE"/>
               <a:t>Textmasterformate durch Klicken bearbeiten</a:t>
             </a:r>
           </a:p>
           <a:p>
             <a:pPr lvl="1"/>
             <a:r>
-              <a:rPr lang="de-DE" smtClean="0"/>
+              <a:rPr lang="de-DE"/>
               <a:t>Zweite Ebene</a:t>
             </a:r>
           </a:p>
           <a:p>
             <a:pPr lvl="2"/>
             <a:r>
-              <a:rPr lang="de-DE" smtClean="0"/>
+              <a:rPr lang="de-DE"/>
               <a:t>Dritte Ebene</a:t>
             </a:r>
           </a:p>
           <a:p>
             <a:pPr lvl="3"/>
             <a:r>
-              <a:rPr lang="de-DE" smtClean="0"/>
+              <a:rPr lang="de-DE"/>
               <a:t>Vierte Ebene</a:t>
             </a:r>
           </a:p>
           <a:p>
             <a:pPr lvl="4"/>
             <a:r>
-              <a:rPr lang="de-DE" smtClean="0"/>
+              <a:rPr lang="de-DE"/>
               <a:t>Fünfte Ebene</a:t>
             </a:r>
-            <a:endParaRPr lang="de-DE"/>
           </a:p>
         </p:txBody>
       </p:sp>
@@ -1638,7 +1640,7 @@
           <a:p>
             <a:pPr lvl="0"/>
             <a:r>
-              <a:rPr lang="de-DE" smtClean="0"/>
+              <a:rPr lang="de-DE"/>
               <a:t>Textmasterformate durch Klicken bearbeiten</a:t>
             </a:r>
           </a:p>
@@ -1694,38 +1696,37 @@
           <a:p>
             <a:pPr lvl="0"/>
             <a:r>
-              <a:rPr lang="de-DE" smtClean="0"/>
+              <a:rPr lang="de-DE"/>
               <a:t>Textmasterformate durch Klicken bearbeiten</a:t>
             </a:r>
           </a:p>
           <a:p>
             <a:pPr lvl="1"/>
             <a:r>
-              <a:rPr lang="de-DE" smtClean="0"/>
+              <a:rPr lang="de-DE"/>
               <a:t>Zweite Ebene</a:t>
             </a:r>
           </a:p>
           <a:p>
             <a:pPr lvl="2"/>
             <a:r>
-              <a:rPr lang="de-DE" smtClean="0"/>
+              <a:rPr lang="de-DE"/>
               <a:t>Dritte Ebene</a:t>
             </a:r>
           </a:p>
           <a:p>
             <a:pPr lvl="3"/>
             <a:r>
-              <a:rPr lang="de-DE" smtClean="0"/>
+              <a:rPr lang="de-DE"/>
               <a:t>Vierte Ebene</a:t>
             </a:r>
           </a:p>
           <a:p>
             <a:pPr lvl="4"/>
             <a:r>
-              <a:rPr lang="de-DE" smtClean="0"/>
+              <a:rPr lang="de-DE"/>
               <a:t>Fünfte Ebene</a:t>
             </a:r>
-            <a:endParaRPr lang="de-DE"/>
           </a:p>
         </p:txBody>
       </p:sp>
@@ -1837,10 +1838,9 @@
           <a:lstStyle/>
           <a:p>
             <a:r>
-              <a:rPr lang="de-DE" smtClean="0"/>
+              <a:rPr lang="de-DE"/>
               <a:t>Titelmasterformat durch Klicken bearbeiten</a:t>
             </a:r>
-            <a:endParaRPr lang="de-DE"/>
           </a:p>
         </p:txBody>
       </p:sp>
@@ -2053,10 +2053,9 @@
           </a:lstStyle>
           <a:p>
             <a:r>
-              <a:rPr lang="de-DE" smtClean="0"/>
+              <a:rPr lang="de-DE"/>
               <a:t>Titelmasterformat durch Klicken bearbeiten</a:t>
             </a:r>
-            <a:endParaRPr lang="de-DE"/>
           </a:p>
         </p:txBody>
       </p:sp>
@@ -2110,38 +2109,37 @@
           <a:p>
             <a:pPr lvl="0"/>
             <a:r>
-              <a:rPr lang="de-DE" smtClean="0"/>
+              <a:rPr lang="de-DE"/>
               <a:t>Textmasterformate durch Klicken bearbeiten</a:t>
             </a:r>
           </a:p>
           <a:p>
             <a:pPr lvl="1"/>
             <a:r>
-              <a:rPr lang="de-DE" smtClean="0"/>
+              <a:rPr lang="de-DE"/>
               <a:t>Zweite Ebene</a:t>
             </a:r>
           </a:p>
           <a:p>
             <a:pPr lvl="2"/>
             <a:r>
-              <a:rPr lang="de-DE" smtClean="0"/>
+              <a:rPr lang="de-DE"/>
               <a:t>Dritte Ebene</a:t>
             </a:r>
           </a:p>
           <a:p>
             <a:pPr lvl="3"/>
             <a:r>
-              <a:rPr lang="de-DE" smtClean="0"/>
+              <a:rPr lang="de-DE"/>
               <a:t>Vierte Ebene</a:t>
             </a:r>
           </a:p>
           <a:p>
             <a:pPr lvl="4"/>
             <a:r>
-              <a:rPr lang="de-DE" smtClean="0"/>
+              <a:rPr lang="de-DE"/>
               <a:t>Fünfte Ebene</a:t>
             </a:r>
-            <a:endParaRPr lang="de-DE"/>
           </a:p>
         </p:txBody>
       </p:sp>
@@ -2204,7 +2202,7 @@
           <a:p>
             <a:pPr lvl="0"/>
             <a:r>
-              <a:rPr lang="de-DE" smtClean="0"/>
+              <a:rPr lang="de-DE"/>
               <a:t>Textmasterformate durch Klicken bearbeiten</a:t>
             </a:r>
           </a:p>
@@ -2327,10 +2325,9 @@
           </a:lstStyle>
           <a:p>
             <a:r>
-              <a:rPr lang="de-DE" smtClean="0"/>
+              <a:rPr lang="de-DE"/>
               <a:t>Titelmasterformat durch Klicken bearbeiten</a:t>
             </a:r>
-            <a:endParaRPr lang="de-DE"/>
           </a:p>
         </p:txBody>
       </p:sp>
@@ -2454,7 +2451,7 @@
           <a:p>
             <a:pPr lvl="0"/>
             <a:r>
-              <a:rPr lang="de-DE" smtClean="0"/>
+              <a:rPr lang="de-DE"/>
               <a:t>Textmasterformate durch Klicken bearbeiten</a:t>
             </a:r>
           </a:p>
@@ -2583,10 +2580,9 @@
           <a:lstStyle/>
           <a:p>
             <a:r>
-              <a:rPr lang="de-DE" smtClean="0"/>
+              <a:rPr lang="de-DE"/>
               <a:t>Titelmasterformat durch Klicken bearbeiten</a:t>
             </a:r>
-            <a:endParaRPr lang="de-DE"/>
           </a:p>
         </p:txBody>
       </p:sp>
@@ -2617,38 +2613,37 @@
           <a:p>
             <a:pPr lvl="0"/>
             <a:r>
-              <a:rPr lang="de-DE" smtClean="0"/>
+              <a:rPr lang="de-DE"/>
               <a:t>Textmasterformate durch Klicken bearbeiten</a:t>
             </a:r>
           </a:p>
           <a:p>
             <a:pPr lvl="1"/>
             <a:r>
-              <a:rPr lang="de-DE" smtClean="0"/>
+              <a:rPr lang="de-DE"/>
               <a:t>Zweite Ebene</a:t>
             </a:r>
           </a:p>
           <a:p>
             <a:pPr lvl="2"/>
             <a:r>
-              <a:rPr lang="de-DE" smtClean="0"/>
+              <a:rPr lang="de-DE"/>
               <a:t>Dritte Ebene</a:t>
             </a:r>
           </a:p>
           <a:p>
             <a:pPr lvl="3"/>
             <a:r>
-              <a:rPr lang="de-DE" smtClean="0"/>
+              <a:rPr lang="de-DE"/>
               <a:t>Vierte Ebene</a:t>
             </a:r>
           </a:p>
           <a:p>
             <a:pPr lvl="4"/>
             <a:r>
-              <a:rPr lang="de-DE" smtClean="0"/>
+              <a:rPr lang="de-DE"/>
               <a:t>Fünfte Ebene</a:t>
             </a:r>
-            <a:endParaRPr lang="de-DE"/>
           </a:p>
         </p:txBody>
       </p:sp>
@@ -3061,7 +3056,13 @@
       </p:grpSpPr>
       <p:grpSp>
         <p:nvGrpSpPr>
-          <p:cNvPr id="19" name="Gruppieren 18"/>
+          <p:cNvPr id="5" name="Gruppieren 4">
+            <a:extLst>
+              <a:ext uri="{FF2B5EF4-FFF2-40B4-BE49-F238E27FC236}">
+                <a16:creationId xmlns:a16="http://schemas.microsoft.com/office/drawing/2014/main" id="{8B467F03-0823-EAD4-9906-68848A50F031}"/>
+              </a:ext>
+            </a:extLst>
+          </p:cNvPr>
           <p:cNvGrpSpPr/>
           <p:nvPr/>
         </p:nvGrpSpPr>
@@ -3073,187 +3074,431 @@
             <a:chExt cx="7179499" cy="2925906"/>
           </a:xfrm>
         </p:grpSpPr>
+        <p:grpSp>
+          <p:nvGrpSpPr>
+            <p:cNvPr id="4" name="Gruppieren 3">
+              <a:extLst>
+                <a:ext uri="{FF2B5EF4-FFF2-40B4-BE49-F238E27FC236}">
+                  <a16:creationId xmlns:a16="http://schemas.microsoft.com/office/drawing/2014/main" id="{433A2B36-E311-791C-3CAC-206BF6B717F5}"/>
+                </a:ext>
+              </a:extLst>
+            </p:cNvPr>
+            <p:cNvGrpSpPr/>
+            <p:nvPr/>
+          </p:nvGrpSpPr>
+          <p:grpSpPr>
+            <a:xfrm>
+              <a:off x="899592" y="2420888"/>
+              <a:ext cx="7179499" cy="2925906"/>
+              <a:chOff x="899592" y="2420888"/>
+              <a:chExt cx="7179499" cy="2925906"/>
+            </a:xfrm>
+          </p:grpSpPr>
+          <p:grpSp>
+            <p:nvGrpSpPr>
+              <p:cNvPr id="19" name="Gruppieren 18"/>
+              <p:cNvGrpSpPr/>
+              <p:nvPr/>
+            </p:nvGrpSpPr>
+            <p:grpSpPr>
+              <a:xfrm>
+                <a:off x="899592" y="2420888"/>
+                <a:ext cx="7179499" cy="2925906"/>
+                <a:chOff x="899592" y="2420888"/>
+                <a:chExt cx="7179499" cy="2925906"/>
+              </a:xfrm>
+            </p:grpSpPr>
+            <p:sp>
+              <p:nvSpPr>
+                <p:cNvPr id="9" name="Geschweifte Klammer links 8"/>
+                <p:cNvSpPr/>
+                <p:nvPr/>
+              </p:nvSpPr>
+              <p:spPr>
+                <a:xfrm rot="16200000">
+                  <a:off x="3311860" y="4545124"/>
+                  <a:ext cx="288032" cy="648072"/>
+                </a:xfrm>
+                <a:prstGeom prst="leftBrace">
+                  <a:avLst/>
+                </a:prstGeom>
+                <a:ln w="12700">
+                  <a:solidFill>
+                    <a:schemeClr val="tx1"/>
+                  </a:solidFill>
+                </a:ln>
+              </p:spPr>
+              <p:style>
+                <a:lnRef idx="1">
+                  <a:schemeClr val="accent1"/>
+                </a:lnRef>
+                <a:fillRef idx="0">
+                  <a:schemeClr val="accent1"/>
+                </a:fillRef>
+                <a:effectRef idx="0">
+                  <a:schemeClr val="accent1"/>
+                </a:effectRef>
+                <a:fontRef idx="minor">
+                  <a:schemeClr val="tx1"/>
+                </a:fontRef>
+              </p:style>
+              <p:txBody>
+                <a:bodyPr rtlCol="0" anchor="ctr"/>
+                <a:lstStyle/>
+                <a:p>
+                  <a:pPr algn="ctr"/>
+                  <a:endParaRPr lang="de-DE"/>
+                </a:p>
+              </p:txBody>
+            </p:sp>
+            <p:sp>
+              <p:nvSpPr>
+                <p:cNvPr id="10" name="Geschweifte Klammer links 9"/>
+                <p:cNvSpPr/>
+                <p:nvPr/>
+              </p:nvSpPr>
+              <p:spPr>
+                <a:xfrm rot="16200000">
+                  <a:off x="4463988" y="4113076"/>
+                  <a:ext cx="288032" cy="1512168"/>
+                </a:xfrm>
+                <a:prstGeom prst="leftBrace">
+                  <a:avLst/>
+                </a:prstGeom>
+                <a:ln w="12700">
+                  <a:solidFill>
+                    <a:schemeClr val="tx1"/>
+                  </a:solidFill>
+                </a:ln>
+              </p:spPr>
+              <p:style>
+                <a:lnRef idx="1">
+                  <a:schemeClr val="accent1"/>
+                </a:lnRef>
+                <a:fillRef idx="0">
+                  <a:schemeClr val="accent1"/>
+                </a:fillRef>
+                <a:effectRef idx="0">
+                  <a:schemeClr val="accent1"/>
+                </a:effectRef>
+                <a:fontRef idx="minor">
+                  <a:schemeClr val="tx1"/>
+                </a:fontRef>
+              </p:style>
+              <p:txBody>
+                <a:bodyPr rtlCol="0" anchor="ctr"/>
+                <a:lstStyle/>
+                <a:p>
+                  <a:pPr algn="ctr"/>
+                  <a:endParaRPr lang="de-DE"/>
+                </a:p>
+              </p:txBody>
+            </p:sp>
+            <p:sp>
+              <p:nvSpPr>
+                <p:cNvPr id="11" name="Geschweifte Klammer links 10"/>
+                <p:cNvSpPr/>
+                <p:nvPr/>
+              </p:nvSpPr>
+              <p:spPr>
+                <a:xfrm rot="16200000">
+                  <a:off x="6228184" y="3933056"/>
+                  <a:ext cx="288032" cy="1872208"/>
+                </a:xfrm>
+                <a:prstGeom prst="leftBrace">
+                  <a:avLst/>
+                </a:prstGeom>
+                <a:ln w="12700">
+                  <a:solidFill>
+                    <a:schemeClr val="tx1"/>
+                  </a:solidFill>
+                </a:ln>
+              </p:spPr>
+              <p:style>
+                <a:lnRef idx="1">
+                  <a:schemeClr val="accent1"/>
+                </a:lnRef>
+                <a:fillRef idx="0">
+                  <a:schemeClr val="accent1"/>
+                </a:fillRef>
+                <a:effectRef idx="0">
+                  <a:schemeClr val="accent1"/>
+                </a:effectRef>
+                <a:fontRef idx="minor">
+                  <a:schemeClr val="tx1"/>
+                </a:fontRef>
+              </p:style>
+              <p:txBody>
+                <a:bodyPr rtlCol="0" anchor="ctr"/>
+                <a:lstStyle/>
+                <a:p>
+                  <a:pPr algn="ctr"/>
+                  <a:endParaRPr lang="de-DE"/>
+                </a:p>
+              </p:txBody>
+            </p:sp>
+            <p:sp>
+              <p:nvSpPr>
+                <p:cNvPr id="12" name="Geschweifte Klammer links 11"/>
+                <p:cNvSpPr/>
+                <p:nvPr/>
+              </p:nvSpPr>
+              <p:spPr>
+                <a:xfrm rot="16200000">
+                  <a:off x="2591780" y="4545124"/>
+                  <a:ext cx="288032" cy="648072"/>
+                </a:xfrm>
+                <a:prstGeom prst="leftBrace">
+                  <a:avLst/>
+                </a:prstGeom>
+                <a:ln w="12700">
+                  <a:solidFill>
+                    <a:schemeClr val="tx1"/>
+                  </a:solidFill>
+                </a:ln>
+              </p:spPr>
+              <p:style>
+                <a:lnRef idx="1">
+                  <a:schemeClr val="accent1"/>
+                </a:lnRef>
+                <a:fillRef idx="0">
+                  <a:schemeClr val="accent1"/>
+                </a:fillRef>
+                <a:effectRef idx="0">
+                  <a:schemeClr val="accent1"/>
+                </a:effectRef>
+                <a:fontRef idx="minor">
+                  <a:schemeClr val="tx1"/>
+                </a:fontRef>
+              </p:style>
+              <p:txBody>
+                <a:bodyPr rtlCol="0" anchor="ctr"/>
+                <a:lstStyle/>
+                <a:p>
+                  <a:pPr algn="ctr"/>
+                  <a:endParaRPr lang="de-DE"/>
+                </a:p>
+              </p:txBody>
+            </p:sp>
+            <p:sp>
+              <p:nvSpPr>
+                <p:cNvPr id="13" name="Textfeld 12"/>
+                <p:cNvSpPr txBox="1"/>
+                <p:nvPr/>
+              </p:nvSpPr>
+              <p:spPr>
+                <a:xfrm>
+                  <a:off x="2195736" y="5085184"/>
+                  <a:ext cx="898003" cy="261610"/>
+                </a:xfrm>
+                <a:prstGeom prst="rect">
+                  <a:avLst/>
+                </a:prstGeom>
+                <a:noFill/>
+              </p:spPr>
+              <p:txBody>
+                <a:bodyPr wrap="none" rtlCol="0">
+                  <a:spAutoFit/>
+                </a:bodyPr>
+                <a:lstStyle/>
+                <a:p>
+                  <a:r>
+                    <a:rPr lang="de-DE" sz="1100" dirty="0" err="1"/>
+                    <a:t>Rectification</a:t>
+                  </a:r>
+                  <a:endParaRPr lang="de-DE" sz="1100" dirty="0"/>
+                </a:p>
+              </p:txBody>
+            </p:sp>
+            <p:sp>
+              <p:nvSpPr>
+                <p:cNvPr id="14" name="Textfeld 13"/>
+                <p:cNvSpPr txBox="1"/>
+                <p:nvPr/>
+              </p:nvSpPr>
+              <p:spPr>
+                <a:xfrm>
+                  <a:off x="2987824" y="5085184"/>
+                  <a:ext cx="1042273" cy="261610"/>
+                </a:xfrm>
+                <a:prstGeom prst="rect">
+                  <a:avLst/>
+                </a:prstGeom>
+                <a:noFill/>
+              </p:spPr>
+              <p:txBody>
+                <a:bodyPr wrap="none" rtlCol="0">
+                  <a:spAutoFit/>
+                </a:bodyPr>
+                <a:lstStyle/>
+                <a:p>
+                  <a:r>
+                    <a:rPr lang="de-DE" sz="1100" dirty="0"/>
+                    <a:t>On/Off </a:t>
+                  </a:r>
+                  <a:r>
+                    <a:rPr lang="de-DE" sz="1100" dirty="0" err="1"/>
+                    <a:t>Control</a:t>
+                  </a:r>
+                  <a:endParaRPr lang="de-DE" sz="1100" dirty="0"/>
+                </a:p>
+              </p:txBody>
+            </p:sp>
+            <p:sp>
+              <p:nvSpPr>
+                <p:cNvPr id="15" name="Textfeld 14"/>
+                <p:cNvSpPr txBox="1"/>
+                <p:nvPr/>
+              </p:nvSpPr>
+              <p:spPr>
+                <a:xfrm>
+                  <a:off x="4139952" y="5085184"/>
+                  <a:ext cx="1064715" cy="261610"/>
+                </a:xfrm>
+                <a:prstGeom prst="rect">
+                  <a:avLst/>
+                </a:prstGeom>
+                <a:noFill/>
+              </p:spPr>
+              <p:txBody>
+                <a:bodyPr wrap="none" rtlCol="0">
+                  <a:spAutoFit/>
+                </a:bodyPr>
+                <a:lstStyle/>
+                <a:p>
+                  <a:r>
+                    <a:rPr lang="de-DE" sz="1100" dirty="0"/>
+                    <a:t>Buck </a:t>
+                  </a:r>
+                  <a:r>
+                    <a:rPr lang="de-DE" sz="1100" dirty="0" err="1"/>
+                    <a:t>Converter</a:t>
+                  </a:r>
+                  <a:endParaRPr lang="de-DE" sz="1100" dirty="0"/>
+                </a:p>
+              </p:txBody>
+            </p:sp>
+            <p:sp>
+              <p:nvSpPr>
+                <p:cNvPr id="16" name="Textfeld 15"/>
+                <p:cNvSpPr txBox="1"/>
+                <p:nvPr/>
+              </p:nvSpPr>
+              <p:spPr>
+                <a:xfrm>
+                  <a:off x="5940152" y="5085184"/>
+                  <a:ext cx="881973" cy="261610"/>
+                </a:xfrm>
+                <a:prstGeom prst="rect">
+                  <a:avLst/>
+                </a:prstGeom>
+                <a:noFill/>
+              </p:spPr>
+              <p:txBody>
+                <a:bodyPr wrap="none" rtlCol="0">
+                  <a:spAutoFit/>
+                </a:bodyPr>
+                <a:lstStyle/>
+                <a:p>
+                  <a:r>
+                    <a:rPr lang="de-DE" sz="1100" dirty="0" err="1"/>
+                    <a:t>Stabilization</a:t>
+                  </a:r>
+                  <a:endParaRPr lang="de-DE" sz="1100" dirty="0"/>
+                </a:p>
+              </p:txBody>
+            </p:sp>
+            <p:pic>
+              <p:nvPicPr>
+                <p:cNvPr id="18" name="Grafik 17" descr="VoltageSupply.png"/>
+                <p:cNvPicPr>
+                  <a:picLocks noChangeAspect="1"/>
+                </p:cNvPicPr>
+                <p:nvPr/>
+              </p:nvPicPr>
+              <p:blipFill>
+                <a:blip r:embed="rId2" cstate="print"/>
+                <a:srcRect l="12815" t="30301" r="8669" b="34158"/>
+                <a:stretch>
+                  <a:fillRect/>
+                </a:stretch>
+              </p:blipFill>
+              <p:spPr>
+                <a:xfrm>
+                  <a:off x="899592" y="2420888"/>
+                  <a:ext cx="7179499" cy="2223267"/>
+                </a:xfrm>
+                <a:prstGeom prst="rect">
+                  <a:avLst/>
+                </a:prstGeom>
+              </p:spPr>
+            </p:pic>
+          </p:grpSp>
+          <p:sp>
+            <p:nvSpPr>
+              <p:cNvPr id="2" name="Geschweifte Klammer links 1">
+                <a:extLst>
+                  <a:ext uri="{FF2B5EF4-FFF2-40B4-BE49-F238E27FC236}">
+                    <a16:creationId xmlns:a16="http://schemas.microsoft.com/office/drawing/2014/main" id="{9EC9D7E8-465D-CB7F-BABF-4ADE3AE71243}"/>
+                  </a:ext>
+                </a:extLst>
+              </p:cNvPr>
+              <p:cNvSpPr/>
+              <p:nvPr/>
+            </p:nvSpPr>
+            <p:spPr>
+              <a:xfrm rot="16200000">
+                <a:off x="1691680" y="4365104"/>
+                <a:ext cx="288032" cy="1008112"/>
+              </a:xfrm>
+              <a:prstGeom prst="leftBrace">
+                <a:avLst/>
+              </a:prstGeom>
+              <a:ln w="12700">
+                <a:solidFill>
+                  <a:schemeClr val="tx1"/>
+                </a:solidFill>
+              </a:ln>
+            </p:spPr>
+            <p:style>
+              <a:lnRef idx="1">
+                <a:schemeClr val="accent1"/>
+              </a:lnRef>
+              <a:fillRef idx="0">
+                <a:schemeClr val="accent1"/>
+              </a:fillRef>
+              <a:effectRef idx="0">
+                <a:schemeClr val="accent1"/>
+              </a:effectRef>
+              <a:fontRef idx="minor">
+                <a:schemeClr val="tx1"/>
+              </a:fontRef>
+            </p:style>
+            <p:txBody>
+              <a:bodyPr rtlCol="0" anchor="ctr"/>
+              <a:lstStyle/>
+              <a:p>
+                <a:pPr algn="ctr"/>
+                <a:endParaRPr lang="de-DE"/>
+              </a:p>
+            </p:txBody>
+          </p:sp>
+        </p:grpSp>
         <p:sp>
           <p:nvSpPr>
-            <p:cNvPr id="9" name="Geschweifte Klammer links 8"/>
-            <p:cNvSpPr/>
-            <p:nvPr/>
-          </p:nvSpPr>
-          <p:spPr>
-            <a:xfrm rot="16200000">
-              <a:off x="3311860" y="4545124"/>
-              <a:ext cx="288032" cy="648072"/>
-            </a:xfrm>
-            <a:prstGeom prst="leftBrace">
-              <a:avLst/>
-            </a:prstGeom>
-            <a:ln w="12700">
-              <a:solidFill>
-                <a:schemeClr val="tx1"/>
-              </a:solidFill>
-            </a:ln>
-          </p:spPr>
-          <p:style>
-            <a:lnRef idx="1">
-              <a:schemeClr val="accent1"/>
-            </a:lnRef>
-            <a:fillRef idx="0">
-              <a:schemeClr val="accent1"/>
-            </a:fillRef>
-            <a:effectRef idx="0">
-              <a:schemeClr val="accent1"/>
-            </a:effectRef>
-            <a:fontRef idx="minor">
-              <a:schemeClr val="tx1"/>
-            </a:fontRef>
-          </p:style>
-          <p:txBody>
-            <a:bodyPr rtlCol="0" anchor="ctr"/>
-            <a:lstStyle/>
-            <a:p>
-              <a:pPr algn="ctr"/>
-              <a:endParaRPr lang="de-DE"/>
-            </a:p>
-          </p:txBody>
-        </p:sp>
-        <p:sp>
-          <p:nvSpPr>
-            <p:cNvPr id="10" name="Geschweifte Klammer links 9"/>
-            <p:cNvSpPr/>
-            <p:nvPr/>
-          </p:nvSpPr>
-          <p:spPr>
-            <a:xfrm rot="16200000">
-              <a:off x="4463988" y="4113076"/>
-              <a:ext cx="288032" cy="1512168"/>
-            </a:xfrm>
-            <a:prstGeom prst="leftBrace">
-              <a:avLst/>
-            </a:prstGeom>
-            <a:ln w="12700">
-              <a:solidFill>
-                <a:schemeClr val="tx1"/>
-              </a:solidFill>
-            </a:ln>
-          </p:spPr>
-          <p:style>
-            <a:lnRef idx="1">
-              <a:schemeClr val="accent1"/>
-            </a:lnRef>
-            <a:fillRef idx="0">
-              <a:schemeClr val="accent1"/>
-            </a:fillRef>
-            <a:effectRef idx="0">
-              <a:schemeClr val="accent1"/>
-            </a:effectRef>
-            <a:fontRef idx="minor">
-              <a:schemeClr val="tx1"/>
-            </a:fontRef>
-          </p:style>
-          <p:txBody>
-            <a:bodyPr rtlCol="0" anchor="ctr"/>
-            <a:lstStyle/>
-            <a:p>
-              <a:pPr algn="ctr"/>
-              <a:endParaRPr lang="de-DE"/>
-            </a:p>
-          </p:txBody>
-        </p:sp>
-        <p:sp>
-          <p:nvSpPr>
-            <p:cNvPr id="11" name="Geschweifte Klammer links 10"/>
-            <p:cNvSpPr/>
-            <p:nvPr/>
-          </p:nvSpPr>
-          <p:spPr>
-            <a:xfrm rot="16200000">
-              <a:off x="6228184" y="3933056"/>
-              <a:ext cx="288032" cy="1872208"/>
-            </a:xfrm>
-            <a:prstGeom prst="leftBrace">
-              <a:avLst/>
-            </a:prstGeom>
-            <a:ln w="12700">
-              <a:solidFill>
-                <a:schemeClr val="tx1"/>
-              </a:solidFill>
-            </a:ln>
-          </p:spPr>
-          <p:style>
-            <a:lnRef idx="1">
-              <a:schemeClr val="accent1"/>
-            </a:lnRef>
-            <a:fillRef idx="0">
-              <a:schemeClr val="accent1"/>
-            </a:fillRef>
-            <a:effectRef idx="0">
-              <a:schemeClr val="accent1"/>
-            </a:effectRef>
-            <a:fontRef idx="minor">
-              <a:schemeClr val="tx1"/>
-            </a:fontRef>
-          </p:style>
-          <p:txBody>
-            <a:bodyPr rtlCol="0" anchor="ctr"/>
-            <a:lstStyle/>
-            <a:p>
-              <a:pPr algn="ctr"/>
-              <a:endParaRPr lang="de-DE"/>
-            </a:p>
-          </p:txBody>
-        </p:sp>
-        <p:sp>
-          <p:nvSpPr>
-            <p:cNvPr id="12" name="Geschweifte Klammer links 11"/>
-            <p:cNvSpPr/>
-            <p:nvPr/>
-          </p:nvSpPr>
-          <p:spPr>
-            <a:xfrm rot="16200000">
-              <a:off x="2591780" y="4545124"/>
-              <a:ext cx="288032" cy="648072"/>
-            </a:xfrm>
-            <a:prstGeom prst="leftBrace">
-              <a:avLst/>
-            </a:prstGeom>
-            <a:ln w="12700">
-              <a:solidFill>
-                <a:schemeClr val="tx1"/>
-              </a:solidFill>
-            </a:ln>
-          </p:spPr>
-          <p:style>
-            <a:lnRef idx="1">
-              <a:schemeClr val="accent1"/>
-            </a:lnRef>
-            <a:fillRef idx="0">
-              <a:schemeClr val="accent1"/>
-            </a:fillRef>
-            <a:effectRef idx="0">
-              <a:schemeClr val="accent1"/>
-            </a:effectRef>
-            <a:fontRef idx="minor">
-              <a:schemeClr val="tx1"/>
-            </a:fontRef>
-          </p:style>
-          <p:txBody>
-            <a:bodyPr rtlCol="0" anchor="ctr"/>
-            <a:lstStyle/>
-            <a:p>
-              <a:pPr algn="ctr"/>
-              <a:endParaRPr lang="de-DE"/>
-            </a:p>
-          </p:txBody>
-        </p:sp>
-        <p:sp>
-          <p:nvSpPr>
-            <p:cNvPr id="13" name="Textfeld 12"/>
+            <p:cNvPr id="3" name="Textfeld 2">
+              <a:extLst>
+                <a:ext uri="{FF2B5EF4-FFF2-40B4-BE49-F238E27FC236}">
+                  <a16:creationId xmlns:a16="http://schemas.microsoft.com/office/drawing/2014/main" id="{B1BB88DD-A82B-9461-F193-3F9AEED336EA}"/>
+                </a:ext>
+              </a:extLst>
+            </p:cNvPr>
             <p:cNvSpPr txBox="1"/>
             <p:nvPr/>
           </p:nvSpPr>
           <p:spPr>
             <a:xfrm>
-              <a:off x="2195736" y="5085184"/>
+              <a:off x="1366466" y="5085184"/>
               <a:ext cx="898003" cy="261610"/>
             </a:xfrm>
             <a:prstGeom prst="rect">
@@ -3268,136 +3513,12 @@
             <a:lstStyle/>
             <a:p>
               <a:r>
-                <a:rPr lang="de-DE" sz="1100" dirty="0" err="1" smtClean="0"/>
-                <a:t>Rectification</a:t>
+                <a:rPr lang="de-DE" sz="1100" dirty="0"/>
+                <a:t>Transformer</a:t>
               </a:r>
-              <a:endParaRPr lang="de-DE" sz="1100" dirty="0"/>
             </a:p>
           </p:txBody>
         </p:sp>
-        <p:sp>
-          <p:nvSpPr>
-            <p:cNvPr id="14" name="Textfeld 13"/>
-            <p:cNvSpPr txBox="1"/>
-            <p:nvPr/>
-          </p:nvSpPr>
-          <p:spPr>
-            <a:xfrm>
-              <a:off x="2987824" y="5085184"/>
-              <a:ext cx="1042273" cy="261610"/>
-            </a:xfrm>
-            <a:prstGeom prst="rect">
-              <a:avLst/>
-            </a:prstGeom>
-            <a:noFill/>
-          </p:spPr>
-          <p:txBody>
-            <a:bodyPr wrap="none" rtlCol="0">
-              <a:spAutoFit/>
-            </a:bodyPr>
-            <a:lstStyle/>
-            <a:p>
-              <a:r>
-                <a:rPr lang="de-DE" sz="1100" dirty="0" smtClean="0"/>
-                <a:t>On/Off </a:t>
-              </a:r>
-              <a:r>
-                <a:rPr lang="de-DE" sz="1100" dirty="0" err="1" smtClean="0"/>
-                <a:t>Control</a:t>
-              </a:r>
-              <a:endParaRPr lang="de-DE" sz="1100" dirty="0"/>
-            </a:p>
-          </p:txBody>
-        </p:sp>
-        <p:sp>
-          <p:nvSpPr>
-            <p:cNvPr id="15" name="Textfeld 14"/>
-            <p:cNvSpPr txBox="1"/>
-            <p:nvPr/>
-          </p:nvSpPr>
-          <p:spPr>
-            <a:xfrm>
-              <a:off x="4139952" y="5085184"/>
-              <a:ext cx="1064715" cy="261610"/>
-            </a:xfrm>
-            <a:prstGeom prst="rect">
-              <a:avLst/>
-            </a:prstGeom>
-            <a:noFill/>
-          </p:spPr>
-          <p:txBody>
-            <a:bodyPr wrap="none" rtlCol="0">
-              <a:spAutoFit/>
-            </a:bodyPr>
-            <a:lstStyle/>
-            <a:p>
-              <a:r>
-                <a:rPr lang="de-DE" sz="1100" dirty="0" smtClean="0"/>
-                <a:t>Buck </a:t>
-              </a:r>
-              <a:r>
-                <a:rPr lang="de-DE" sz="1100" dirty="0" err="1" smtClean="0"/>
-                <a:t>Converter</a:t>
-              </a:r>
-              <a:endParaRPr lang="de-DE" sz="1100" dirty="0"/>
-            </a:p>
-          </p:txBody>
-        </p:sp>
-        <p:sp>
-          <p:nvSpPr>
-            <p:cNvPr id="16" name="Textfeld 15"/>
-            <p:cNvSpPr txBox="1"/>
-            <p:nvPr/>
-          </p:nvSpPr>
-          <p:spPr>
-            <a:xfrm>
-              <a:off x="5940152" y="5085184"/>
-              <a:ext cx="881973" cy="261610"/>
-            </a:xfrm>
-            <a:prstGeom prst="rect">
-              <a:avLst/>
-            </a:prstGeom>
-            <a:noFill/>
-          </p:spPr>
-          <p:txBody>
-            <a:bodyPr wrap="none" rtlCol="0">
-              <a:spAutoFit/>
-            </a:bodyPr>
-            <a:lstStyle/>
-            <a:p>
-              <a:r>
-                <a:rPr lang="de-DE" sz="1100" dirty="0" err="1" smtClean="0"/>
-                <a:t>Stabilization</a:t>
-              </a:r>
-              <a:endParaRPr lang="de-DE" sz="1100" dirty="0"/>
-            </a:p>
-          </p:txBody>
-        </p:sp>
-        <p:pic>
-          <p:nvPicPr>
-            <p:cNvPr id="18" name="Grafik 17" descr="VoltageSupply.png"/>
-            <p:cNvPicPr>
-              <a:picLocks noChangeAspect="1"/>
-            </p:cNvPicPr>
-            <p:nvPr/>
-          </p:nvPicPr>
-          <p:blipFill>
-            <a:blip r:embed="rId2" cstate="print"/>
-            <a:srcRect l="12815" t="30301" r="8669" b="34158"/>
-            <a:stretch>
-              <a:fillRect/>
-            </a:stretch>
-          </p:blipFill>
-          <p:spPr>
-            <a:xfrm>
-              <a:off x="899592" y="2420888"/>
-              <a:ext cx="7179499" cy="2223267"/>
-            </a:xfrm>
-            <a:prstGeom prst="rect">
-              <a:avLst/>
-            </a:prstGeom>
-          </p:spPr>
-        </p:pic>
       </p:grpSp>
     </p:spTree>
   </p:cSld>

</xml_diff>